<commit_message>
chore(reports): refresh world-trends-housing artefacts
Updated report outputs (docx/pptx/md/json/png) and eval/overnight logs
from recent pipeline runs. No code changes.

Co-Authored-By: Claude Opus 4.7 <noreply@anthropic.com>
</commit_message>
<xml_diff>
--- a/reports/20260415-world-trends-housing.pptx
+++ b/reports/20260415-world-trends-housing.pptx
@@ -13,6 +13,14 @@
     <p:sldId id="261" r:id="rId12"/>
     <p:sldId id="262" r:id="rId13"/>
     <p:sldId id="263" r:id="rId14"/>
+    <p:sldId id="264" r:id="rId15"/>
+    <p:sldId id="265" r:id="rId16"/>
+    <p:sldId id="266" r:id="rId17"/>
+    <p:sldId id="267" r:id="rId18"/>
+    <p:sldId id="268" r:id="rId19"/>
+    <p:sldId id="269" r:id="rId20"/>
+    <p:sldId id="270" r:id="rId21"/>
+    <p:sldId id="271" r:id="rId22"/>
   </p:sldIdLst>
   <p:sldSz cx="12191695" cy="6858000" type="screen4x3"/>
   <p:notesSz cx="6858000" cy="9144000"/>
@@ -3281,7 +3289,1599 @@
                 </a:solidFill>
                 <a:latin typeface="Arial"/>
               </a:rPr>
-              <a:t>5 доменов  ·  0 блоков  ·  0 связей</a:t>
+              <a:t>5 доменов  ·  15 блоков  ·  10 связей</a:t>
+            </a:r>
+          </a:p>
+        </p:txBody>
+      </p:sp>
+    </p:spTree>
+  </p:cSld>
+  <p:clrMapOvr>
+    <a:masterClrMapping/>
+  </p:clrMapOvr>
+</p:sld>
+</file>
+
+<file path=ppt/slides/slide10.xml><?xml version="1.0" encoding="utf-8"?>
+<p:sld xmlns:a="http://schemas.openxmlformats.org/drawingml/2006/main" xmlns:p="http://schemas.openxmlformats.org/presentationml/2006/main" xmlns:r="http://schemas.openxmlformats.org/officeDocument/2006/relationships">
+  <p:cSld>
+    <p:spTree>
+      <p:nvGrpSpPr>
+        <p:cNvPr id="1" name=""/>
+        <p:cNvGrpSpPr/>
+        <p:nvPr/>
+      </p:nvGrpSpPr>
+      <p:grpSpPr/>
+      <p:sp>
+        <p:nvSpPr>
+          <p:cNvPr id="2" name="Rectangle 1"/>
+          <p:cNvSpPr/>
+          <p:nvPr/>
+        </p:nvSpPr>
+        <p:spPr>
+          <a:xfrm>
+            <a:off x="360000" y="360000"/>
+            <a:ext cx="72000" cy="540000"/>
+          </a:xfrm>
+          <a:prstGeom prst="rect">
+            <a:avLst/>
+          </a:prstGeom>
+          <a:solidFill>
+            <a:srgbClr val="1B3A5C"/>
+          </a:solidFill>
+          <a:ln>
+            <a:noFill/>
+          </a:ln>
+        </p:spPr>
+        <p:style>
+          <a:lnRef idx="1">
+            <a:schemeClr val="accent1"/>
+          </a:lnRef>
+          <a:fillRef idx="3">
+            <a:schemeClr val="accent1"/>
+          </a:fillRef>
+          <a:effectRef idx="2">
+            <a:schemeClr val="accent1"/>
+          </a:effectRef>
+          <a:fontRef idx="minor">
+            <a:schemeClr val="lt1"/>
+          </a:fontRef>
+        </p:style>
+        <p:txBody>
+          <a:bodyPr rtlCol="0" anchor="ctr"/>
+          <a:lstStyle/>
+          <a:p>
+            <a:pPr algn="ctr"/>
+          </a:p>
+        </p:txBody>
+      </p:sp>
+      <p:sp>
+        <p:nvSpPr>
+          <p:cNvPr id="3" name="TextBox 2"/>
+          <p:cNvSpPr txBox="1"/>
+          <p:nvPr/>
+        </p:nvSpPr>
+        <p:spPr>
+          <a:xfrm>
+            <a:off x="540000" y="360000"/>
+            <a:ext cx="11111695" cy="360000"/>
+          </a:xfrm>
+          <a:prstGeom prst="rect">
+            <a:avLst/>
+          </a:prstGeom>
+          <a:noFill/>
+        </p:spPr>
+        <p:txBody>
+          <a:bodyPr wrap="square" lIns="36000" rIns="36000" tIns="18000" bIns="18000">
+            <a:spAutoFit/>
+          </a:bodyPr>
+          <a:lstStyle/>
+          <a:p>
+            <a:pPr algn="l"/>
+            <a:r>
+              <a:rPr sz="1400" b="1" i="0">
+                <a:solidFill>
+                  <a:srgbClr val="1B3A5C"/>
+                </a:solidFill>
+                <a:latin typeface="Arial"/>
+              </a:rPr>
+              <a:t>ГРАФ КРОСС-ДОМЕННЫХ СВЯЗЕЙ</a:t>
+            </a:r>
+          </a:p>
+        </p:txBody>
+      </p:sp>
+      <p:sp>
+        <p:nvSpPr>
+          <p:cNvPr id="4" name="TextBox 3"/>
+          <p:cNvSpPr txBox="1"/>
+          <p:nvPr/>
+        </p:nvSpPr>
+        <p:spPr>
+          <a:xfrm>
+            <a:off x="360000" y="720000"/>
+            <a:ext cx="11471695" cy="360000"/>
+          </a:xfrm>
+          <a:prstGeom prst="rect">
+            <a:avLst/>
+          </a:prstGeom>
+          <a:noFill/>
+        </p:spPr>
+        <p:txBody>
+          <a:bodyPr wrap="square" lIns="36000" rIns="36000" tIns="18000" bIns="18000">
+            <a:spAutoFit/>
+          </a:bodyPr>
+          <a:lstStyle/>
+          <a:p>
+            <a:pPr algn="l"/>
+            <a:r>
+              <a:rPr sz="1200" b="0" i="1">
+                <a:solidFill>
+                  <a:srgbClr val="555555"/>
+                </a:solidFill>
+                <a:latin typeface="Arial"/>
+              </a:rPr>
+              <a:t>Цвет ребра = тип связи, толщина = сила</a:t>
+            </a:r>
+          </a:p>
+        </p:txBody>
+      </p:sp>
+      <p:pic>
+        <p:nvPicPr>
+          <p:cNvPr id="5" name="Picture 4" descr="20260415-world-trends-housing-graph.png"/>
+          <p:cNvPicPr>
+            <a:picLocks noChangeAspect="1"/>
+          </p:cNvPicPr>
+          <p:nvPr/>
+        </p:nvPicPr>
+        <p:blipFill>
+          <a:blip r:embed="rId2"/>
+          <a:stretch>
+            <a:fillRect/>
+          </a:stretch>
+        </p:blipFill>
+        <p:spPr>
+          <a:xfrm>
+            <a:off x="3641871" y="1260000"/>
+            <a:ext cx="4907953" cy="5058000"/>
+          </a:xfrm>
+          <a:prstGeom prst="rect">
+            <a:avLst/>
+          </a:prstGeom>
+        </p:spPr>
+      </p:pic>
+    </p:spTree>
+  </p:cSld>
+  <p:clrMapOvr>
+    <a:masterClrMapping/>
+  </p:clrMapOvr>
+</p:sld>
+</file>
+
+<file path=ppt/slides/slide11.xml><?xml version="1.0" encoding="utf-8"?>
+<p:sld xmlns:a="http://schemas.openxmlformats.org/drawingml/2006/main" xmlns:p="http://schemas.openxmlformats.org/presentationml/2006/main" xmlns:r="http://schemas.openxmlformats.org/officeDocument/2006/relationships">
+  <p:cSld>
+    <p:spTree>
+      <p:nvGrpSpPr>
+        <p:cNvPr id="1" name=""/>
+        <p:cNvGrpSpPr/>
+        <p:nvPr/>
+      </p:nvGrpSpPr>
+      <p:grpSpPr/>
+      <p:sp>
+        <p:nvSpPr>
+          <p:cNvPr id="2" name="Rectangle 1"/>
+          <p:cNvSpPr/>
+          <p:nvPr/>
+        </p:nvSpPr>
+        <p:spPr>
+          <a:xfrm>
+            <a:off x="360000" y="360000"/>
+            <a:ext cx="72000" cy="540000"/>
+          </a:xfrm>
+          <a:prstGeom prst="rect">
+            <a:avLst/>
+          </a:prstGeom>
+          <a:solidFill>
+            <a:srgbClr val="2E86C1"/>
+          </a:solidFill>
+          <a:ln>
+            <a:noFill/>
+          </a:ln>
+        </p:spPr>
+        <p:style>
+          <a:lnRef idx="1">
+            <a:schemeClr val="accent1"/>
+          </a:lnRef>
+          <a:fillRef idx="3">
+            <a:schemeClr val="accent1"/>
+          </a:fillRef>
+          <a:effectRef idx="2">
+            <a:schemeClr val="accent1"/>
+          </a:effectRef>
+          <a:fontRef idx="minor">
+            <a:schemeClr val="lt1"/>
+          </a:fontRef>
+        </p:style>
+        <p:txBody>
+          <a:bodyPr rtlCol="0" anchor="ctr"/>
+          <a:lstStyle/>
+          <a:p>
+            <a:pPr algn="ctr"/>
+          </a:p>
+        </p:txBody>
+      </p:sp>
+      <p:sp>
+        <p:nvSpPr>
+          <p:cNvPr id="3" name="TextBox 2"/>
+          <p:cNvSpPr txBox="1"/>
+          <p:nvPr/>
+        </p:nvSpPr>
+        <p:spPr>
+          <a:xfrm>
+            <a:off x="540000" y="360000"/>
+            <a:ext cx="11111695" cy="360000"/>
+          </a:xfrm>
+          <a:prstGeom prst="rect">
+            <a:avLst/>
+          </a:prstGeom>
+          <a:noFill/>
+        </p:spPr>
+        <p:txBody>
+          <a:bodyPr wrap="square" lIns="36000" rIns="36000" tIns="18000" bIns="18000">
+            <a:spAutoFit/>
+          </a:bodyPr>
+          <a:lstStyle/>
+          <a:p>
+            <a:pPr algn="l"/>
+            <a:r>
+              <a:rPr sz="1400" b="1" i="0">
+                <a:solidFill>
+                  <a:srgbClr val="2E86C1"/>
+                </a:solidFill>
+                <a:latin typeface="Arial"/>
+              </a:rPr>
+              <a:t>СВЯЗЬ #1 · 🔗 ПРИЧИННАЯ ЦЕПОЧКА</a:t>
+            </a:r>
+          </a:p>
+        </p:txBody>
+      </p:sp>
+      <p:sp>
+        <p:nvSpPr>
+          <p:cNvPr id="4" name="TextBox 3"/>
+          <p:cNvSpPr txBox="1"/>
+          <p:nvPr/>
+        </p:nvSpPr>
+        <p:spPr>
+          <a:xfrm>
+            <a:off x="360000" y="1080000"/>
+            <a:ext cx="11471695" cy="540000"/>
+          </a:xfrm>
+          <a:prstGeom prst="rect">
+            <a:avLst/>
+          </a:prstGeom>
+          <a:noFill/>
+        </p:spPr>
+        <p:txBody>
+          <a:bodyPr wrap="square" lIns="36000" rIns="36000" tIns="18000" bIns="18000">
+            <a:spAutoFit/>
+          </a:bodyPr>
+          <a:lstStyle/>
+          <a:p>
+            <a:pPr algn="l"/>
+            <a:r>
+              <a:rPr sz="2000" b="1" i="0">
+                <a:solidFill>
+                  <a:srgbClr val="1B3A5C"/>
+                </a:solidFill>
+                <a:latin typeface="Arial"/>
+              </a:rPr>
+              <a:t>Демография и миграционные потоки / Миграционная динамика в РФ ↔ Технологии и цифровизация строительства / Глобальные инновации</a:t>
+            </a:r>
+          </a:p>
+        </p:txBody>
+      </p:sp>
+      <p:sp>
+        <p:nvSpPr>
+          <p:cNvPr id="5" name="TextBox 4"/>
+          <p:cNvSpPr txBox="1"/>
+          <p:nvPr/>
+        </p:nvSpPr>
+        <p:spPr>
+          <a:xfrm>
+            <a:off x="360000" y="1800000"/>
+            <a:ext cx="11471695" cy="1800000"/>
+          </a:xfrm>
+          <a:prstGeom prst="rect">
+            <a:avLst/>
+          </a:prstGeom>
+          <a:noFill/>
+        </p:spPr>
+        <p:txBody>
+          <a:bodyPr wrap="square" lIns="36000" rIns="36000" tIns="18000" bIns="18000">
+            <a:spAutoFit/>
+          </a:bodyPr>
+          <a:lstStyle/>
+          <a:p>
+            <a:pPr algn="l"/>
+            <a:r>
+              <a:rPr sz="1400" b="0" i="0">
+                <a:solidFill>
+                  <a:srgbClr val="1B3A5C"/>
+                </a:solidFill>
+                <a:latin typeface="Arial"/>
+              </a:rPr>
+              <a:t>Сокращение трудоспособного населения создаёт структурный дефицит кадров в строительстве, что делает традиционные методы экономически неэффективными. Это вынуждает отрасль форсировать внедрение цифровых двойников и автоматизации для компенсации нехватки рабочих рук, несмотря на регуляторные барьеры.</a:t>
+            </a:r>
+          </a:p>
+        </p:txBody>
+      </p:sp>
+      <p:sp>
+        <p:nvSpPr>
+          <p:cNvPr id="6" name="TextBox 5"/>
+          <p:cNvSpPr txBox="1"/>
+          <p:nvPr/>
+        </p:nvSpPr>
+        <p:spPr>
+          <a:xfrm>
+            <a:off x="360000" y="3960000"/>
+            <a:ext cx="11471695" cy="900000"/>
+          </a:xfrm>
+          <a:prstGeom prst="rect">
+            <a:avLst/>
+          </a:prstGeom>
+          <a:noFill/>
+        </p:spPr>
+        <p:txBody>
+          <a:bodyPr wrap="square" lIns="36000" rIns="36000" tIns="18000" bIns="18000">
+            <a:spAutoFit/>
+          </a:bodyPr>
+          <a:lstStyle/>
+          <a:p>
+            <a:pPr algn="l"/>
+            <a:r>
+              <a:rPr sz="1200" b="0" i="1">
+                <a:solidFill>
+                  <a:srgbClr val="555555"/>
+                </a:solidFill>
+                <a:latin typeface="Arial"/>
+              </a:rPr>
+              <a:t>Что нового: Цифровизация и автоматизация в строительстве — не технологический тренд, а вынужденная демографическая адаптация; без них отрасль столкнётся с коллапсом себестоимости к 2030 году.</a:t>
+            </a:r>
+          </a:p>
+        </p:txBody>
+      </p:sp>
+      <p:sp>
+        <p:nvSpPr>
+          <p:cNvPr id="7" name="TextBox 6"/>
+          <p:cNvSpPr txBox="1"/>
+          <p:nvPr/>
+        </p:nvSpPr>
+        <p:spPr>
+          <a:xfrm>
+            <a:off x="360000" y="5040000"/>
+            <a:ext cx="2880000" cy="360000"/>
+          </a:xfrm>
+          <a:prstGeom prst="rect">
+            <a:avLst/>
+          </a:prstGeom>
+          <a:noFill/>
+        </p:spPr>
+        <p:txBody>
+          <a:bodyPr wrap="square" lIns="36000" rIns="36000" tIns="18000" bIns="18000">
+            <a:spAutoFit/>
+          </a:bodyPr>
+          <a:lstStyle/>
+          <a:p>
+            <a:pPr algn="l"/>
+            <a:r>
+              <a:rPr sz="1000" b="0" i="0">
+                <a:solidFill>
+                  <a:srgbClr val="555555"/>
+                </a:solidFill>
+                <a:latin typeface="Arial"/>
+              </a:rPr>
+              <a:t>Сила: strong  ·  Общая переменная: трудовой дефицит и производительность</a:t>
+            </a:r>
+          </a:p>
+        </p:txBody>
+      </p:sp>
+    </p:spTree>
+  </p:cSld>
+  <p:clrMapOvr>
+    <a:masterClrMapping/>
+  </p:clrMapOvr>
+</p:sld>
+</file>
+
+<file path=ppt/slides/slide12.xml><?xml version="1.0" encoding="utf-8"?>
+<p:sld xmlns:a="http://schemas.openxmlformats.org/drawingml/2006/main" xmlns:p="http://schemas.openxmlformats.org/presentationml/2006/main" xmlns:r="http://schemas.openxmlformats.org/officeDocument/2006/relationships">
+  <p:cSld>
+    <p:spTree>
+      <p:nvGrpSpPr>
+        <p:cNvPr id="1" name=""/>
+        <p:cNvGrpSpPr/>
+        <p:nvPr/>
+      </p:nvGrpSpPr>
+      <p:grpSpPr/>
+      <p:sp>
+        <p:nvSpPr>
+          <p:cNvPr id="2" name="Rectangle 1"/>
+          <p:cNvSpPr/>
+          <p:nvPr/>
+        </p:nvSpPr>
+        <p:spPr>
+          <a:xfrm>
+            <a:off x="360000" y="360000"/>
+            <a:ext cx="72000" cy="540000"/>
+          </a:xfrm>
+          <a:prstGeom prst="rect">
+            <a:avLst/>
+          </a:prstGeom>
+          <a:solidFill>
+            <a:srgbClr val="C0392B"/>
+          </a:solidFill>
+          <a:ln>
+            <a:noFill/>
+          </a:ln>
+        </p:spPr>
+        <p:style>
+          <a:lnRef idx="1">
+            <a:schemeClr val="accent1"/>
+          </a:lnRef>
+          <a:fillRef idx="3">
+            <a:schemeClr val="accent1"/>
+          </a:fillRef>
+          <a:effectRef idx="2">
+            <a:schemeClr val="accent1"/>
+          </a:effectRef>
+          <a:fontRef idx="minor">
+            <a:schemeClr val="lt1"/>
+          </a:fontRef>
+        </p:style>
+        <p:txBody>
+          <a:bodyPr rtlCol="0" anchor="ctr"/>
+          <a:lstStyle/>
+          <a:p>
+            <a:pPr algn="ctr"/>
+          </a:p>
+        </p:txBody>
+      </p:sp>
+      <p:sp>
+        <p:nvSpPr>
+          <p:cNvPr id="3" name="TextBox 2"/>
+          <p:cNvSpPr txBox="1"/>
+          <p:nvPr/>
+        </p:nvSpPr>
+        <p:spPr>
+          <a:xfrm>
+            <a:off x="540000" y="360000"/>
+            <a:ext cx="11111695" cy="360000"/>
+          </a:xfrm>
+          <a:prstGeom prst="rect">
+            <a:avLst/>
+          </a:prstGeom>
+          <a:noFill/>
+        </p:spPr>
+        <p:txBody>
+          <a:bodyPr wrap="square" lIns="36000" rIns="36000" tIns="18000" bIns="18000">
+            <a:spAutoFit/>
+          </a:bodyPr>
+          <a:lstStyle/>
+          <a:p>
+            <a:pPr algn="l"/>
+            <a:r>
+              <a:rPr sz="1400" b="1" i="0">
+                <a:solidFill>
+                  <a:srgbClr val="C0392B"/>
+                </a:solidFill>
+                <a:latin typeface="Arial"/>
+              </a:rPr>
+              <a:t>СВЯЗЬ #2 · ⚡ ПАРАДОКС</a:t>
+            </a:r>
+          </a:p>
+        </p:txBody>
+      </p:sp>
+      <p:sp>
+        <p:nvSpPr>
+          <p:cNvPr id="4" name="TextBox 3"/>
+          <p:cNvSpPr txBox="1"/>
+          <p:nvPr/>
+        </p:nvSpPr>
+        <p:spPr>
+          <a:xfrm>
+            <a:off x="360000" y="1080000"/>
+            <a:ext cx="11471695" cy="540000"/>
+          </a:xfrm>
+          <a:prstGeom prst="rect">
+            <a:avLst/>
+          </a:prstGeom>
+          <a:noFill/>
+        </p:spPr>
+        <p:txBody>
+          <a:bodyPr wrap="square" lIns="36000" rIns="36000" tIns="18000" bIns="18000">
+            <a:spAutoFit/>
+          </a:bodyPr>
+          <a:lstStyle/>
+          <a:p>
+            <a:pPr algn="l"/>
+            <a:r>
+              <a:rPr sz="2000" b="1" i="0">
+                <a:solidFill>
+                  <a:srgbClr val="1B3A5C"/>
+                </a:solidFill>
+                <a:latin typeface="Arial"/>
+              </a:rPr>
+              <a:t>Социокультурные паттерны и урбанистика / Российские практики расселения ↔ Демография и миграционные потоки / Структура домохозяйств и типология спроса</a:t>
+            </a:r>
+          </a:p>
+        </p:txBody>
+      </p:sp>
+      <p:sp>
+        <p:nvSpPr>
+          <p:cNvPr id="5" name="TextBox 4"/>
+          <p:cNvSpPr txBox="1"/>
+          <p:nvPr/>
+        </p:nvSpPr>
+        <p:spPr>
+          <a:xfrm>
+            <a:off x="360000" y="1800000"/>
+            <a:ext cx="11471695" cy="1800000"/>
+          </a:xfrm>
+          <a:prstGeom prst="rect">
+            <a:avLst/>
+          </a:prstGeom>
+          <a:noFill/>
+        </p:spPr>
+        <p:txBody>
+          <a:bodyPr wrap="square" lIns="36000" rIns="36000" tIns="18000" bIns="18000">
+            <a:spAutoFit/>
+          </a:bodyPr>
+          <a:lstStyle/>
+          <a:p>
+            <a:pPr algn="l"/>
+            <a:r>
+              <a:rPr sz="1400" b="0" i="0">
+                <a:solidFill>
+                  <a:srgbClr val="1B3A5C"/>
+                </a:solidFill>
+                <a:latin typeface="Arial"/>
+              </a:rPr>
+              <a:t>Потребители массово декларируют спрос на семейное жильё (3+ комнат), но реальная демография показывает доминирование одиноких домохозяйств (41,8%). Рынок реагирует на платёжеспособный спрос, наращивая долю студий и ИЖС, что создаёт хронический дефицит формально востребованных квартир.</a:t>
+            </a:r>
+          </a:p>
+        </p:txBody>
+      </p:sp>
+      <p:sp>
+        <p:nvSpPr>
+          <p:cNvPr id="6" name="TextBox 5"/>
+          <p:cNvSpPr txBox="1"/>
+          <p:nvPr/>
+        </p:nvSpPr>
+        <p:spPr>
+          <a:xfrm>
+            <a:off x="360000" y="3960000"/>
+            <a:ext cx="11471695" cy="900000"/>
+          </a:xfrm>
+          <a:prstGeom prst="rect">
+            <a:avLst/>
+          </a:prstGeom>
+          <a:noFill/>
+        </p:spPr>
+        <p:txBody>
+          <a:bodyPr wrap="square" lIns="36000" rIns="36000" tIns="18000" bIns="18000">
+            <a:spAutoFit/>
+          </a:bodyPr>
+          <a:lstStyle/>
+          <a:p>
+            <a:pPr algn="l"/>
+            <a:r>
+              <a:rPr sz="1200" b="0" i="1">
+                <a:solidFill>
+                  <a:srgbClr val="555555"/>
+                </a:solidFill>
+                <a:latin typeface="Arial"/>
+              </a:rPr>
+              <a:t>Что нового: Декларируемые предпочтения покупателей расходятся с демографической реальностью; девелоперы строят под фактический состав домохозяйств, а не под заявленные желания, что ведёт к долгосрочной стагнации рынка семейных квартир.</a:t>
+            </a:r>
+          </a:p>
+        </p:txBody>
+      </p:sp>
+      <p:sp>
+        <p:nvSpPr>
+          <p:cNvPr id="7" name="TextBox 6"/>
+          <p:cNvSpPr txBox="1"/>
+          <p:nvPr/>
+        </p:nvSpPr>
+        <p:spPr>
+          <a:xfrm>
+            <a:off x="360000" y="5040000"/>
+            <a:ext cx="2880000" cy="360000"/>
+          </a:xfrm>
+          <a:prstGeom prst="rect">
+            <a:avLst/>
+          </a:prstGeom>
+          <a:noFill/>
+        </p:spPr>
+        <p:txBody>
+          <a:bodyPr wrap="square" lIns="36000" rIns="36000" tIns="18000" bIns="18000">
+            <a:spAutoFit/>
+          </a:bodyPr>
+          <a:lstStyle/>
+          <a:p>
+            <a:pPr algn="l"/>
+            <a:r>
+              <a:rPr sz="1000" b="0" i="0">
+                <a:solidFill>
+                  <a:srgbClr val="555555"/>
+                </a:solidFill>
+                <a:latin typeface="Arial"/>
+              </a:rPr>
+              <a:t>Сила: strong  ·  Общая переменная: структура жилищного предложения</a:t>
+            </a:r>
+          </a:p>
+        </p:txBody>
+      </p:sp>
+    </p:spTree>
+  </p:cSld>
+  <p:clrMapOvr>
+    <a:masterClrMapping/>
+  </p:clrMapOvr>
+</p:sld>
+</file>
+
+<file path=ppt/slides/slide13.xml><?xml version="1.0" encoding="utf-8"?>
+<p:sld xmlns:a="http://schemas.openxmlformats.org/drawingml/2006/main" xmlns:p="http://schemas.openxmlformats.org/presentationml/2006/main" xmlns:r="http://schemas.openxmlformats.org/officeDocument/2006/relationships">
+  <p:cSld>
+    <p:spTree>
+      <p:nvGrpSpPr>
+        <p:cNvPr id="1" name=""/>
+        <p:cNvGrpSpPr/>
+        <p:nvPr/>
+      </p:nvGrpSpPr>
+      <p:grpSpPr/>
+      <p:sp>
+        <p:nvSpPr>
+          <p:cNvPr id="2" name="Rectangle 1"/>
+          <p:cNvSpPr/>
+          <p:nvPr/>
+        </p:nvSpPr>
+        <p:spPr>
+          <a:xfrm>
+            <a:off x="360000" y="360000"/>
+            <a:ext cx="72000" cy="540000"/>
+          </a:xfrm>
+          <a:prstGeom prst="rect">
+            <a:avLst/>
+          </a:prstGeom>
+          <a:solidFill>
+            <a:srgbClr val="2E5984"/>
+          </a:solidFill>
+          <a:ln>
+            <a:noFill/>
+          </a:ln>
+        </p:spPr>
+        <p:style>
+          <a:lnRef idx="1">
+            <a:schemeClr val="accent1"/>
+          </a:lnRef>
+          <a:fillRef idx="3">
+            <a:schemeClr val="accent1"/>
+          </a:fillRef>
+          <a:effectRef idx="2">
+            <a:schemeClr val="accent1"/>
+          </a:effectRef>
+          <a:fontRef idx="minor">
+            <a:schemeClr val="lt1"/>
+          </a:fontRef>
+        </p:style>
+        <p:txBody>
+          <a:bodyPr rtlCol="0" anchor="ctr"/>
+          <a:lstStyle/>
+          <a:p>
+            <a:pPr algn="ctr"/>
+          </a:p>
+        </p:txBody>
+      </p:sp>
+      <p:sp>
+        <p:nvSpPr>
+          <p:cNvPr id="3" name="TextBox 2"/>
+          <p:cNvSpPr txBox="1"/>
+          <p:nvPr/>
+        </p:nvSpPr>
+        <p:spPr>
+          <a:xfrm>
+            <a:off x="540000" y="360000"/>
+            <a:ext cx="11111695" cy="360000"/>
+          </a:xfrm>
+          <a:prstGeom prst="rect">
+            <a:avLst/>
+          </a:prstGeom>
+          <a:noFill/>
+        </p:spPr>
+        <p:txBody>
+          <a:bodyPr wrap="square" lIns="36000" rIns="36000" tIns="18000" bIns="18000">
+            <a:spAutoFit/>
+          </a:bodyPr>
+          <a:lstStyle/>
+          <a:p>
+            <a:pPr algn="l"/>
+            <a:r>
+              <a:rPr sz="1400" b="1" i="0">
+                <a:solidFill>
+                  <a:srgbClr val="2E5984"/>
+                </a:solidFill>
+                <a:latin typeface="Arial"/>
+              </a:rPr>
+              <a:t>СВЯЗЬ #3 · ◇ ОБЩАЯ ПЕРЕМЕННАЯ</a:t>
+            </a:r>
+          </a:p>
+        </p:txBody>
+      </p:sp>
+      <p:sp>
+        <p:nvSpPr>
+          <p:cNvPr id="4" name="TextBox 3"/>
+          <p:cNvSpPr txBox="1"/>
+          <p:nvPr/>
+        </p:nvSpPr>
+        <p:spPr>
+          <a:xfrm>
+            <a:off x="360000" y="1080000"/>
+            <a:ext cx="11471695" cy="540000"/>
+          </a:xfrm>
+          <a:prstGeom prst="rect">
+            <a:avLst/>
+          </a:prstGeom>
+          <a:noFill/>
+        </p:spPr>
+        <p:txBody>
+          <a:bodyPr wrap="square" lIns="36000" rIns="36000" tIns="18000" bIns="18000">
+            <a:spAutoFit/>
+          </a:bodyPr>
+          <a:lstStyle/>
+          <a:p>
+            <a:pPr algn="l"/>
+            <a:r>
+              <a:rPr sz="2000" b="1" i="0">
+                <a:solidFill>
+                  <a:srgbClr val="1B3A5C"/>
+                </a:solidFill>
+                <a:latin typeface="Arial"/>
+              </a:rPr>
+              <a:t>Макроэкономика и финансирование девелопмента / Российская финансовая экосистема ↔ Экология и климатическая адаптация / Глобальные климатические риски и ESG ↔ Технологии и цифровизация строительства / Экономика внедрения</a:t>
+            </a:r>
+          </a:p>
+        </p:txBody>
+      </p:sp>
+      <p:sp>
+        <p:nvSpPr>
+          <p:cNvPr id="5" name="TextBox 4"/>
+          <p:cNvSpPr txBox="1"/>
+          <p:nvPr/>
+        </p:nvSpPr>
+        <p:spPr>
+          <a:xfrm>
+            <a:off x="360000" y="1800000"/>
+            <a:ext cx="11471695" cy="1800000"/>
+          </a:xfrm>
+          <a:prstGeom prst="rect">
+            <a:avLst/>
+          </a:prstGeom>
+          <a:noFill/>
+        </p:spPr>
+        <p:txBody>
+          <a:bodyPr wrap="square" lIns="36000" rIns="36000" tIns="18000" bIns="18000">
+            <a:spAutoFit/>
+          </a:bodyPr>
+          <a:lstStyle/>
+          <a:p>
+            <a:pPr algn="l"/>
+            <a:r>
+              <a:rPr sz="1400" b="0" i="0">
+                <a:solidFill>
+                  <a:srgbClr val="1B3A5C"/>
+                </a:solidFill>
+                <a:latin typeface="Arial"/>
+              </a:rPr>
+              <a:t>Высокие ставки по кредитам МСП (~20-24%) делают окупаемость цифровых и ESG-решений критически зависимой от скорости возврата инвестиций. Заявленный кредитный дисконт 2% за ESG-практики нивелируется базовой стоимостью долга, оставляя рентабельными только проекты с окупаемостью до 1-2 лет.</a:t>
+            </a:r>
+          </a:p>
+        </p:txBody>
+      </p:sp>
+      <p:sp>
+        <p:nvSpPr>
+          <p:cNvPr id="6" name="TextBox 5"/>
+          <p:cNvSpPr txBox="1"/>
+          <p:nvPr/>
+        </p:nvSpPr>
+        <p:spPr>
+          <a:xfrm>
+            <a:off x="360000" y="3960000"/>
+            <a:ext cx="11471695" cy="900000"/>
+          </a:xfrm>
+          <a:prstGeom prst="rect">
+            <a:avLst/>
+          </a:prstGeom>
+          <a:noFill/>
+        </p:spPr>
+        <p:txBody>
+          <a:bodyPr wrap="square" lIns="36000" rIns="36000" tIns="18000" bIns="18000">
+            <a:spAutoFit/>
+          </a:bodyPr>
+          <a:lstStyle/>
+          <a:p>
+            <a:pPr algn="l"/>
+            <a:r>
+              <a:rPr sz="1200" b="0" i="1">
+                <a:solidFill>
+                  <a:srgbClr val="555555"/>
+                </a:solidFill>
+                <a:latin typeface="Arial"/>
+              </a:rPr>
+              <a:t>Что нового: В условиях жёсткой монетарной политики ESG-льготы и цифровизация перестают быть стратегическими инвестициями и становятся инструментом выживания только для крупных игроков с доступом к дешёвому капиталу.</a:t>
+            </a:r>
+          </a:p>
+        </p:txBody>
+      </p:sp>
+      <p:sp>
+        <p:nvSpPr>
+          <p:cNvPr id="7" name="TextBox 6"/>
+          <p:cNvSpPr txBox="1"/>
+          <p:nvPr/>
+        </p:nvSpPr>
+        <p:spPr>
+          <a:xfrm>
+            <a:off x="360000" y="5040000"/>
+            <a:ext cx="2880000" cy="360000"/>
+          </a:xfrm>
+          <a:prstGeom prst="rect">
+            <a:avLst/>
+          </a:prstGeom>
+          <a:noFill/>
+        </p:spPr>
+        <p:txBody>
+          <a:bodyPr wrap="square" lIns="36000" rIns="36000" tIns="18000" bIns="18000">
+            <a:spAutoFit/>
+          </a:bodyPr>
+          <a:lstStyle/>
+          <a:p>
+            <a:pPr algn="l"/>
+            <a:r>
+              <a:rPr sz="1000" b="0" i="0">
+                <a:solidFill>
+                  <a:srgbClr val="555555"/>
+                </a:solidFill>
+                <a:latin typeface="Arial"/>
+              </a:rPr>
+              <a:t>Сила: moderate  ·  Общая переменная: стоимость заёмного капитала</a:t>
+            </a:r>
+          </a:p>
+        </p:txBody>
+      </p:sp>
+    </p:spTree>
+  </p:cSld>
+  <p:clrMapOvr>
+    <a:masterClrMapping/>
+  </p:clrMapOvr>
+</p:sld>
+</file>
+
+<file path=ppt/slides/slide14.xml><?xml version="1.0" encoding="utf-8"?>
+<p:sld xmlns:a="http://schemas.openxmlformats.org/drawingml/2006/main" xmlns:p="http://schemas.openxmlformats.org/presentationml/2006/main" xmlns:r="http://schemas.openxmlformats.org/officeDocument/2006/relationships">
+  <p:cSld>
+    <p:spTree>
+      <p:nvGrpSpPr>
+        <p:cNvPr id="1" name=""/>
+        <p:cNvGrpSpPr/>
+        <p:nvPr/>
+      </p:nvGrpSpPr>
+      <p:grpSpPr/>
+      <p:sp>
+        <p:nvSpPr>
+          <p:cNvPr id="2" name="Rectangle 1"/>
+          <p:cNvSpPr/>
+          <p:nvPr/>
+        </p:nvSpPr>
+        <p:spPr>
+          <a:xfrm>
+            <a:off x="360000" y="360000"/>
+            <a:ext cx="72000" cy="540000"/>
+          </a:xfrm>
+          <a:prstGeom prst="rect">
+            <a:avLst/>
+          </a:prstGeom>
+          <a:solidFill>
+            <a:srgbClr val="1B3A5C"/>
+          </a:solidFill>
+          <a:ln>
+            <a:noFill/>
+          </a:ln>
+        </p:spPr>
+        <p:style>
+          <a:lnRef idx="1">
+            <a:schemeClr val="accent1"/>
+          </a:lnRef>
+          <a:fillRef idx="3">
+            <a:schemeClr val="accent1"/>
+          </a:fillRef>
+          <a:effectRef idx="2">
+            <a:schemeClr val="accent1"/>
+          </a:effectRef>
+          <a:fontRef idx="minor">
+            <a:schemeClr val="lt1"/>
+          </a:fontRef>
+        </p:style>
+        <p:txBody>
+          <a:bodyPr rtlCol="0" anchor="ctr"/>
+          <a:lstStyle/>
+          <a:p>
+            <a:pPr algn="ctr"/>
+          </a:p>
+        </p:txBody>
+      </p:sp>
+      <p:sp>
+        <p:nvSpPr>
+          <p:cNvPr id="3" name="TextBox 2"/>
+          <p:cNvSpPr txBox="1"/>
+          <p:nvPr/>
+        </p:nvSpPr>
+        <p:spPr>
+          <a:xfrm>
+            <a:off x="540000" y="360000"/>
+            <a:ext cx="11111695" cy="360000"/>
+          </a:xfrm>
+          <a:prstGeom prst="rect">
+            <a:avLst/>
+          </a:prstGeom>
+          <a:noFill/>
+        </p:spPr>
+        <p:txBody>
+          <a:bodyPr wrap="square" lIns="36000" rIns="36000" tIns="18000" bIns="18000">
+            <a:spAutoFit/>
+          </a:bodyPr>
+          <a:lstStyle/>
+          <a:p>
+            <a:pPr algn="l"/>
+            <a:r>
+              <a:rPr sz="1400" b="1" i="0">
+                <a:solidFill>
+                  <a:srgbClr val="1B3A5C"/>
+                </a:solidFill>
+                <a:latin typeface="Arial"/>
+              </a:rPr>
+              <a:t>ТЕПЛОВАЯ КАРТА ПРИОРИТЕТОВ</a:t>
+            </a:r>
+          </a:p>
+        </p:txBody>
+      </p:sp>
+      <p:sp>
+        <p:nvSpPr>
+          <p:cNvPr id="4" name="TextBox 3"/>
+          <p:cNvSpPr txBox="1"/>
+          <p:nvPr/>
+        </p:nvSpPr>
+        <p:spPr>
+          <a:xfrm>
+            <a:off x="360000" y="720000"/>
+            <a:ext cx="11471695" cy="360000"/>
+          </a:xfrm>
+          <a:prstGeom prst="rect">
+            <a:avLst/>
+          </a:prstGeom>
+          <a:noFill/>
+        </p:spPr>
+        <p:txBody>
+          <a:bodyPr wrap="square" lIns="36000" rIns="36000" tIns="18000" bIns="18000">
+            <a:spAutoFit/>
+          </a:bodyPr>
+          <a:lstStyle/>
+          <a:p>
+            <a:pPr algn="l"/>
+            <a:r>
+              <a:rPr sz="1200" b="0" i="1">
+                <a:solidFill>
+                  <a:srgbClr val="555555"/>
+                </a:solidFill>
+                <a:latin typeface="Arial"/>
+              </a:rPr>
+              <a:t>Где золото, где пусто</a:t>
+            </a:r>
+          </a:p>
+        </p:txBody>
+      </p:sp>
+      <p:pic>
+        <p:nvPicPr>
+          <p:cNvPr id="5" name="Picture 4" descr="20260415-world-trends-housing-heatmap.png"/>
+          <p:cNvPicPr>
+            <a:picLocks noChangeAspect="1"/>
+          </p:cNvPicPr>
+          <p:nvPr/>
+        </p:nvPicPr>
+        <p:blipFill>
+          <a:blip r:embed="rId2"/>
+          <a:stretch>
+            <a:fillRect/>
+          </a:stretch>
+        </p:blipFill>
+        <p:spPr>
+          <a:xfrm>
+            <a:off x="2116080" y="1260000"/>
+            <a:ext cx="7959535" cy="5058000"/>
+          </a:xfrm>
+          <a:prstGeom prst="rect">
+            <a:avLst/>
+          </a:prstGeom>
+        </p:spPr>
+      </p:pic>
+    </p:spTree>
+  </p:cSld>
+  <p:clrMapOvr>
+    <a:masterClrMapping/>
+  </p:clrMapOvr>
+</p:sld>
+</file>
+
+<file path=ppt/slides/slide15.xml><?xml version="1.0" encoding="utf-8"?>
+<p:sld xmlns:a="http://schemas.openxmlformats.org/drawingml/2006/main" xmlns:p="http://schemas.openxmlformats.org/presentationml/2006/main" xmlns:r="http://schemas.openxmlformats.org/officeDocument/2006/relationships">
+  <p:cSld>
+    <p:spTree>
+      <p:nvGrpSpPr>
+        <p:cNvPr id="1" name=""/>
+        <p:cNvGrpSpPr/>
+        <p:nvPr/>
+      </p:nvGrpSpPr>
+      <p:grpSpPr/>
+      <p:sp>
+        <p:nvSpPr>
+          <p:cNvPr id="2" name="Rectangle 1"/>
+          <p:cNvSpPr/>
+          <p:nvPr/>
+        </p:nvSpPr>
+        <p:spPr>
+          <a:xfrm>
+            <a:off x="360000" y="360000"/>
+            <a:ext cx="72000" cy="540000"/>
+          </a:xfrm>
+          <a:prstGeom prst="rect">
+            <a:avLst/>
+          </a:prstGeom>
+          <a:solidFill>
+            <a:srgbClr val="C0392B"/>
+          </a:solidFill>
+          <a:ln>
+            <a:noFill/>
+          </a:ln>
+        </p:spPr>
+        <p:style>
+          <a:lnRef idx="1">
+            <a:schemeClr val="accent1"/>
+          </a:lnRef>
+          <a:fillRef idx="3">
+            <a:schemeClr val="accent1"/>
+          </a:fillRef>
+          <a:effectRef idx="2">
+            <a:schemeClr val="accent1"/>
+          </a:effectRef>
+          <a:fontRef idx="minor">
+            <a:schemeClr val="lt1"/>
+          </a:fontRef>
+        </p:style>
+        <p:txBody>
+          <a:bodyPr rtlCol="0" anchor="ctr"/>
+          <a:lstStyle/>
+          <a:p>
+            <a:pPr algn="ctr"/>
+          </a:p>
+        </p:txBody>
+      </p:sp>
+      <p:sp>
+        <p:nvSpPr>
+          <p:cNvPr id="3" name="TextBox 2"/>
+          <p:cNvSpPr txBox="1"/>
+          <p:nvPr/>
+        </p:nvSpPr>
+        <p:spPr>
+          <a:xfrm>
+            <a:off x="540000" y="360000"/>
+            <a:ext cx="11111695" cy="360000"/>
+          </a:xfrm>
+          <a:prstGeom prst="rect">
+            <a:avLst/>
+          </a:prstGeom>
+          <a:noFill/>
+        </p:spPr>
+        <p:txBody>
+          <a:bodyPr wrap="square" lIns="36000" rIns="36000" tIns="18000" bIns="18000">
+            <a:spAutoFit/>
+          </a:bodyPr>
+          <a:lstStyle/>
+          <a:p>
+            <a:pPr algn="l"/>
+            <a:r>
+              <a:rPr sz="1400" b="1" i="0">
+                <a:solidFill>
+                  <a:srgbClr val="1B3A5C"/>
+                </a:solidFill>
+                <a:latin typeface="Arial"/>
+              </a:rPr>
+              <a:t>КРИТИЧЕСКИЕ ПРОБЕЛЫ И СЛЕДУЮЩИЕ ШАГИ</a:t>
+            </a:r>
+          </a:p>
+        </p:txBody>
+      </p:sp>
+      <p:sp>
+        <p:nvSpPr>
+          <p:cNvPr id="4" name="Oval 3"/>
+          <p:cNvSpPr/>
+          <p:nvPr/>
+        </p:nvSpPr>
+        <p:spPr>
+          <a:xfrm>
+            <a:off x="360000" y="1152000"/>
+            <a:ext cx="144000" cy="144000"/>
+          </a:xfrm>
+          <a:prstGeom prst="ellipse">
+            <a:avLst/>
+          </a:prstGeom>
+          <a:solidFill>
+            <a:srgbClr val="C0392B"/>
+          </a:solidFill>
+          <a:ln>
+            <a:noFill/>
+          </a:ln>
+        </p:spPr>
+        <p:style>
+          <a:lnRef idx="1">
+            <a:schemeClr val="accent1"/>
+          </a:lnRef>
+          <a:fillRef idx="3">
+            <a:schemeClr val="accent1"/>
+          </a:fillRef>
+          <a:effectRef idx="2">
+            <a:schemeClr val="accent1"/>
+          </a:effectRef>
+          <a:fontRef idx="minor">
+            <a:schemeClr val="lt1"/>
+          </a:fontRef>
+        </p:style>
+        <p:txBody>
+          <a:bodyPr rtlCol="0" anchor="ctr"/>
+          <a:lstStyle/>
+          <a:p>
+            <a:pPr algn="ctr"/>
+          </a:p>
+        </p:txBody>
+      </p:sp>
+      <p:sp>
+        <p:nvSpPr>
+          <p:cNvPr id="5" name="TextBox 4"/>
+          <p:cNvSpPr txBox="1"/>
+          <p:nvPr/>
+        </p:nvSpPr>
+        <p:spPr>
+          <a:xfrm>
+            <a:off x="720000" y="1080000"/>
+            <a:ext cx="11111695" cy="540000"/>
+          </a:xfrm>
+          <a:prstGeom prst="rect">
+            <a:avLst/>
+          </a:prstGeom>
+          <a:noFill/>
+        </p:spPr>
+        <p:txBody>
+          <a:bodyPr wrap="square" lIns="36000" rIns="36000" tIns="18000" bIns="18000">
+            <a:spAutoFit/>
+          </a:bodyPr>
+          <a:lstStyle/>
+          <a:p>
+            <a:pPr algn="l"/>
+            <a:r>
+              <a:rPr sz="1400" b="0" i="0">
+                <a:solidFill>
+                  <a:srgbClr val="1B3A5C"/>
+                </a:solidFill>
+                <a:latin typeface="Arial"/>
+              </a:rPr>
+              <a:t>Найти прямые отчёты McKinsey/BCG/Gartner по цифровизации и автоматизации строительства на 2024–2030 гг. для верификации отраслевых прогнозов.</a:t>
+            </a:r>
+          </a:p>
+        </p:txBody>
+      </p:sp>
+      <p:sp>
+        <p:nvSpPr>
+          <p:cNvPr id="6" name="Oval 5"/>
+          <p:cNvSpPr/>
+          <p:nvPr/>
+        </p:nvSpPr>
+        <p:spPr>
+          <a:xfrm>
+            <a:off x="360000" y="1800000"/>
+            <a:ext cx="144000" cy="144000"/>
+          </a:xfrm>
+          <a:prstGeom prst="ellipse">
+            <a:avLst/>
+          </a:prstGeom>
+          <a:solidFill>
+            <a:srgbClr val="C0392B"/>
+          </a:solidFill>
+          <a:ln>
+            <a:noFill/>
+          </a:ln>
+        </p:spPr>
+        <p:style>
+          <a:lnRef idx="1">
+            <a:schemeClr val="accent1"/>
+          </a:lnRef>
+          <a:fillRef idx="3">
+            <a:schemeClr val="accent1"/>
+          </a:fillRef>
+          <a:effectRef idx="2">
+            <a:schemeClr val="accent1"/>
+          </a:effectRef>
+          <a:fontRef idx="minor">
+            <a:schemeClr val="lt1"/>
+          </a:fontRef>
+        </p:style>
+        <p:txBody>
+          <a:bodyPr rtlCol="0" anchor="ctr"/>
+          <a:lstStyle/>
+          <a:p>
+            <a:pPr algn="ctr"/>
+          </a:p>
+        </p:txBody>
+      </p:sp>
+      <p:sp>
+        <p:nvSpPr>
+          <p:cNvPr id="7" name="TextBox 6"/>
+          <p:cNvSpPr txBox="1"/>
+          <p:nvPr/>
+        </p:nvSpPr>
+        <p:spPr>
+          <a:xfrm>
+            <a:off x="720000" y="1728000"/>
+            <a:ext cx="11111695" cy="540000"/>
+          </a:xfrm>
+          <a:prstGeom prst="rect">
+            <a:avLst/>
+          </a:prstGeom>
+          <a:noFill/>
+        </p:spPr>
+        <p:txBody>
+          <a:bodyPr wrap="square" lIns="36000" rIns="36000" tIns="18000" bIns="18000">
+            <a:spAutoFit/>
+          </a:bodyPr>
+          <a:lstStyle/>
+          <a:p>
+            <a:pPr algn="l"/>
+            <a:r>
+              <a:rPr sz="1400" b="0" i="0">
+                <a:solidFill>
+                  <a:srgbClr val="1B3A5C"/>
+                </a:solidFill>
+                <a:latin typeface="Arial"/>
+              </a:rPr>
+              <a:t>Запросить актуальные данные МВД и Росстата по внутренней миграции за 2024–2025 гг. с разбивкой по ФО для уточнения региональных прогнозов спроса.</a:t>
+            </a:r>
+          </a:p>
+        </p:txBody>
+      </p:sp>
+      <p:sp>
+        <p:nvSpPr>
+          <p:cNvPr id="8" name="Oval 7"/>
+          <p:cNvSpPr/>
+          <p:nvPr/>
+        </p:nvSpPr>
+        <p:spPr>
+          <a:xfrm>
+            <a:off x="360000" y="2448000"/>
+            <a:ext cx="144000" cy="144000"/>
+          </a:xfrm>
+          <a:prstGeom prst="ellipse">
+            <a:avLst/>
+          </a:prstGeom>
+          <a:solidFill>
+            <a:srgbClr val="C0392B"/>
+          </a:solidFill>
+          <a:ln>
+            <a:noFill/>
+          </a:ln>
+        </p:spPr>
+        <p:style>
+          <a:lnRef idx="1">
+            <a:schemeClr val="accent1"/>
+          </a:lnRef>
+          <a:fillRef idx="3">
+            <a:schemeClr val="accent1"/>
+          </a:fillRef>
+          <a:effectRef idx="2">
+            <a:schemeClr val="accent1"/>
+          </a:effectRef>
+          <a:fontRef idx="minor">
+            <a:schemeClr val="lt1"/>
+          </a:fontRef>
+        </p:style>
+        <p:txBody>
+          <a:bodyPr rtlCol="0" anchor="ctr"/>
+          <a:lstStyle/>
+          <a:p>
+            <a:pPr algn="ctr"/>
+          </a:p>
+        </p:txBody>
+      </p:sp>
+      <p:sp>
+        <p:nvSpPr>
+          <p:cNvPr id="9" name="TextBox 8"/>
+          <p:cNvSpPr txBox="1"/>
+          <p:nvPr/>
+        </p:nvSpPr>
+        <p:spPr>
+          <a:xfrm>
+            <a:off x="720000" y="2376000"/>
+            <a:ext cx="11111695" cy="540000"/>
+          </a:xfrm>
+          <a:prstGeom prst="rect">
+            <a:avLst/>
+          </a:prstGeom>
+          <a:noFill/>
+        </p:spPr>
+        <p:txBody>
+          <a:bodyPr wrap="square" lIns="36000" rIns="36000" tIns="18000" bIns="18000">
+            <a:spAutoFit/>
+          </a:bodyPr>
+          <a:lstStyle/>
+          <a:p>
+            <a:pPr algn="l"/>
+            <a:r>
+              <a:rPr sz="1400" b="0" i="0">
+                <a:solidFill>
+                  <a:srgbClr val="1B3A5C"/>
+                </a:solidFill>
+                <a:latin typeface="Arial"/>
+              </a:rPr>
+              <a:t>Оценить фактическое влияние изменений 214-ФЗ и требований к капиталу застройщиков на консолидацию рынка и вход МСБ в сегмент.</a:t>
+            </a:r>
+          </a:p>
+        </p:txBody>
+      </p:sp>
+      <p:sp>
+        <p:nvSpPr>
+          <p:cNvPr id="10" name="Oval 9"/>
+          <p:cNvSpPr/>
+          <p:nvPr/>
+        </p:nvSpPr>
+        <p:spPr>
+          <a:xfrm>
+            <a:off x="360000" y="3096000"/>
+            <a:ext cx="144000" cy="144000"/>
+          </a:xfrm>
+          <a:prstGeom prst="ellipse">
+            <a:avLst/>
+          </a:prstGeom>
+          <a:solidFill>
+            <a:srgbClr val="C0392B"/>
+          </a:solidFill>
+          <a:ln>
+            <a:noFill/>
+          </a:ln>
+        </p:spPr>
+        <p:style>
+          <a:lnRef idx="1">
+            <a:schemeClr val="accent1"/>
+          </a:lnRef>
+          <a:fillRef idx="3">
+            <a:schemeClr val="accent1"/>
+          </a:fillRef>
+          <a:effectRef idx="2">
+            <a:schemeClr val="accent1"/>
+          </a:effectRef>
+          <a:fontRef idx="minor">
+            <a:schemeClr val="lt1"/>
+          </a:fontRef>
+        </p:style>
+        <p:txBody>
+          <a:bodyPr rtlCol="0" anchor="ctr"/>
+          <a:lstStyle/>
+          <a:p>
+            <a:pPr algn="ctr"/>
+          </a:p>
+        </p:txBody>
+      </p:sp>
+      <p:sp>
+        <p:nvSpPr>
+          <p:cNvPr id="11" name="TextBox 10"/>
+          <p:cNvSpPr txBox="1"/>
+          <p:nvPr/>
+        </p:nvSpPr>
+        <p:spPr>
+          <a:xfrm>
+            <a:off x="720000" y="3024000"/>
+            <a:ext cx="11111695" cy="540000"/>
+          </a:xfrm>
+          <a:prstGeom prst="rect">
+            <a:avLst/>
+          </a:prstGeom>
+          <a:noFill/>
+        </p:spPr>
+        <p:txBody>
+          <a:bodyPr wrap="square" lIns="36000" rIns="36000" tIns="18000" bIns="18000">
+            <a:spAutoFit/>
+          </a:bodyPr>
+          <a:lstStyle/>
+          <a:p>
+            <a:pPr algn="l"/>
+            <a:r>
+              <a:rPr sz="1400" b="0" i="0">
+                <a:solidFill>
+                  <a:srgbClr val="1B3A5C"/>
+                </a:solidFill>
+                <a:latin typeface="Arial"/>
+              </a:rPr>
+              <a:t>Собрать статистику страховых выплат и тарифов по климатическим рискам (паводки, мерзлота) в регионах РФ за 2022–2024 гг.</a:t>
+            </a:r>
+          </a:p>
+        </p:txBody>
+      </p:sp>
+    </p:spTree>
+  </p:cSld>
+  <p:clrMapOvr>
+    <a:masterClrMapping/>
+  </p:clrMapOvr>
+</p:sld>
+</file>
+
+<file path=ppt/slides/slide16.xml><?xml version="1.0" encoding="utf-8"?>
+<p:sld xmlns:a="http://schemas.openxmlformats.org/drawingml/2006/main" xmlns:p="http://schemas.openxmlformats.org/presentationml/2006/main" xmlns:r="http://schemas.openxmlformats.org/officeDocument/2006/relationships">
+  <p:cSld>
+    <p:spTree>
+      <p:nvGrpSpPr>
+        <p:cNvPr id="1" name=""/>
+        <p:cNvGrpSpPr/>
+        <p:nvPr/>
+      </p:nvGrpSpPr>
+      <p:grpSpPr/>
+      <p:sp>
+        <p:nvSpPr>
+          <p:cNvPr id="2" name="Rectangle 1"/>
+          <p:cNvSpPr/>
+          <p:nvPr/>
+        </p:nvSpPr>
+        <p:spPr>
+          <a:xfrm>
+            <a:off x="0" y="0"/>
+            <a:ext cx="12191695" cy="6858000"/>
+          </a:xfrm>
+          <a:prstGeom prst="rect">
+            <a:avLst/>
+          </a:prstGeom>
+          <a:solidFill>
+            <a:srgbClr val="1B3A5C"/>
+          </a:solidFill>
+          <a:ln>
+            <a:noFill/>
+          </a:ln>
+        </p:spPr>
+        <p:style>
+          <a:lnRef idx="1">
+            <a:schemeClr val="accent1"/>
+          </a:lnRef>
+          <a:fillRef idx="3">
+            <a:schemeClr val="accent1"/>
+          </a:fillRef>
+          <a:effectRef idx="2">
+            <a:schemeClr val="accent1"/>
+          </a:effectRef>
+          <a:fontRef idx="minor">
+            <a:schemeClr val="lt1"/>
+          </a:fontRef>
+        </p:style>
+        <p:txBody>
+          <a:bodyPr rtlCol="0" anchor="ctr"/>
+          <a:lstStyle/>
+          <a:p>
+            <a:pPr algn="ctr"/>
+          </a:p>
+        </p:txBody>
+      </p:sp>
+      <p:sp>
+        <p:nvSpPr>
+          <p:cNvPr id="3" name="TextBox 2"/>
+          <p:cNvSpPr txBox="1"/>
+          <p:nvPr/>
+        </p:nvSpPr>
+        <p:spPr>
+          <a:xfrm>
+            <a:off x="360000" y="1080000"/>
+            <a:ext cx="11471695" cy="720000"/>
+          </a:xfrm>
+          <a:prstGeom prst="rect">
+            <a:avLst/>
+          </a:prstGeom>
+          <a:noFill/>
+        </p:spPr>
+        <p:txBody>
+          <a:bodyPr wrap="square" lIns="36000" rIns="36000" tIns="18000" bIns="18000">
+            <a:spAutoFit/>
+          </a:bodyPr>
+          <a:lstStyle/>
+          <a:p>
+            <a:pPr algn="l"/>
+            <a:r>
+              <a:rPr sz="1400" b="1" i="0">
+                <a:solidFill>
+                  <a:srgbClr val="FFFFFF"/>
+                </a:solidFill>
+                <a:latin typeface="Arial"/>
+              </a:rPr>
+              <a:t>ЗАКЛЮЧЕНИЕ</a:t>
+            </a:r>
+          </a:p>
+        </p:txBody>
+      </p:sp>
+      <p:sp>
+        <p:nvSpPr>
+          <p:cNvPr id="4" name="TextBox 3"/>
+          <p:cNvSpPr txBox="1"/>
+          <p:nvPr/>
+        </p:nvSpPr>
+        <p:spPr>
+          <a:xfrm>
+            <a:off x="360000" y="2160000"/>
+            <a:ext cx="11471695" cy="1080000"/>
+          </a:xfrm>
+          <a:prstGeom prst="rect">
+            <a:avLst/>
+          </a:prstGeom>
+          <a:noFill/>
+        </p:spPr>
+        <p:txBody>
+          <a:bodyPr wrap="square" lIns="36000" rIns="36000" tIns="18000" bIns="18000">
+            <a:spAutoFit/>
+          </a:bodyPr>
+          <a:lstStyle/>
+          <a:p>
+            <a:pPr algn="l"/>
+            <a:r>
+              <a:rPr sz="2600" b="1" i="0">
+                <a:solidFill>
+                  <a:srgbClr val="FFFFFF"/>
+                </a:solidFill>
+                <a:latin typeface="Arial"/>
+              </a:rPr>
+              <a:t>5 доменов · 15 блоков · 10 связей</a:t>
+            </a:r>
+          </a:p>
+        </p:txBody>
+      </p:sp>
+      <p:sp>
+        <p:nvSpPr>
+          <p:cNvPr id="5" name="TextBox 4"/>
+          <p:cNvSpPr txBox="1"/>
+          <p:nvPr/>
+        </p:nvSpPr>
+        <p:spPr>
+          <a:xfrm>
+            <a:off x="360000" y="3960000"/>
+            <a:ext cx="11471695" cy="1080000"/>
+          </a:xfrm>
+          <a:prstGeom prst="rect">
+            <a:avLst/>
+          </a:prstGeom>
+          <a:noFill/>
+        </p:spPr>
+        <p:txBody>
+          <a:bodyPr wrap="square" lIns="36000" rIns="36000" tIns="18000" bIns="18000">
+            <a:spAutoFit/>
+          </a:bodyPr>
+          <a:lstStyle/>
+          <a:p>
+            <a:pPr algn="l"/>
+            <a:r>
+              <a:rPr sz="1800" b="0" i="1">
+                <a:solidFill>
+                  <a:srgbClr val="FFFFFF"/>
+                </a:solidFill>
+                <a:latin typeface="Arial"/>
+              </a:rPr>
+              <a:t>Цифровые двойники ускоряют реализацию проектов на ~25%, что подтверждено практиками мониторинга на объектах «Лахта Центр» и «Бирюлевское» (itweek.ru).</a:t>
             </a:r>
           </a:p>
         </p:txBody>
@@ -3413,6 +5013,41 @@
                 <a:latin typeface="Arial"/>
               </a:rPr>
               <a:t>Какие мировые тренды 2025–2030 повлияют на жилое строительство в России — технологические, демографические, экономические, культурные, экологические</a:t>
+            </a:r>
+          </a:p>
+        </p:txBody>
+      </p:sp>
+      <p:sp>
+        <p:nvSpPr>
+          <p:cNvPr id="5" name="TextBox 4"/>
+          <p:cNvSpPr txBox="1"/>
+          <p:nvPr/>
+        </p:nvSpPr>
+        <p:spPr>
+          <a:xfrm>
+            <a:off x="360000" y="2880000"/>
+            <a:ext cx="11471695" cy="1800000"/>
+          </a:xfrm>
+          <a:prstGeom prst="rect">
+            <a:avLst/>
+          </a:prstGeom>
+          <a:noFill/>
+        </p:spPr>
+        <p:txBody>
+          <a:bodyPr wrap="square" lIns="36000" rIns="36000" tIns="18000" bIns="18000">
+            <a:spAutoFit/>
+          </a:bodyPr>
+          <a:lstStyle/>
+          <a:p>
+            <a:pPr algn="l"/>
+            <a:r>
+              <a:rPr sz="1400" b="0" i="0">
+                <a:solidFill>
+                  <a:srgbClr val="555555"/>
+                </a:solidFill>
+                <a:latin typeface="Arial"/>
+              </a:rPr>
+              <a:t>Отчёт выявляет ключевые технологические, демографические, макроэкономические, социокультурные и экологические тренды 2025–2030 гг., определяющие трансформацию российского жилого строительства.</a:t>
             </a:r>
           </a:p>
         </p:txBody>
@@ -3719,8 +5354,8 @@
         </p:blipFill>
         <p:spPr>
           <a:xfrm>
-            <a:off x="2069227" y="1260000"/>
-            <a:ext cx="8053240" cy="5058000"/>
+            <a:off x="2063576" y="1260000"/>
+            <a:ext cx="8064542" cy="5058000"/>
           </a:xfrm>
           <a:prstGeom prst="rect">
             <a:avLst/>
@@ -3797,7 +5432,7 @@
         <p:spPr>
           <a:xfrm>
             <a:off x="540000" y="360000"/>
-            <a:ext cx="11111695" cy="360000"/>
+            <a:ext cx="3600000" cy="360000"/>
           </a:xfrm>
           <a:prstGeom prst="rect">
             <a:avLst/>
@@ -3818,7 +5453,7 @@
                 </a:solidFill>
                 <a:latin typeface="Arial"/>
               </a:rPr>
-              <a:t>ГРАФ КРОСС-ДОМЕННЫХ СВЯЗЕЙ</a:t>
+              <a:t>НАХОДКА #1</a:t>
             </a:r>
           </a:p>
         </p:txBody>
@@ -3831,8 +5466,8 @@
         </p:nvSpPr>
         <p:spPr>
           <a:xfrm>
-            <a:off x="360000" y="720000"/>
-            <a:ext cx="11471695" cy="360000"/>
+            <a:off x="360000" y="1080000"/>
+            <a:ext cx="11471695" cy="1440000"/>
           </a:xfrm>
           <a:prstGeom prst="rect">
             <a:avLst/>
@@ -3847,41 +5482,87 @@
           <a:p>
             <a:pPr algn="l"/>
             <a:r>
-              <a:rPr sz="1200" b="0" i="1">
-                <a:solidFill>
-                  <a:srgbClr val="555555"/>
+              <a:rPr sz="2200" b="1" i="0">
+                <a:solidFill>
+                  <a:srgbClr val="1B3A5C"/>
                 </a:solidFill>
                 <a:latin typeface="Arial"/>
               </a:rPr>
-              <a:t>Цвет ребра = тип связи, толщина = сила</a:t>
-            </a:r>
-          </a:p>
-        </p:txBody>
-      </p:sp>
-      <p:pic>
-        <p:nvPicPr>
-          <p:cNvPr id="5" name="Picture 4" descr="20260415-world-trends-housing-graph.png"/>
-          <p:cNvPicPr>
-            <a:picLocks noChangeAspect="1"/>
-          </p:cNvPicPr>
-          <p:nvPr/>
-        </p:nvPicPr>
-        <p:blipFill>
-          <a:blip r:embed="rId2"/>
-          <a:stretch>
-            <a:fillRect/>
-          </a:stretch>
-        </p:blipFill>
-        <p:spPr>
-          <a:xfrm>
-            <a:off x="3641871" y="1260000"/>
-            <a:ext cx="4907953" cy="5058000"/>
-          </a:xfrm>
-          <a:prstGeom prst="rect">
-            <a:avLst/>
-          </a:prstGeom>
-        </p:spPr>
-      </p:pic>
+              <a:t>Цифровые двойники ускоряют реализацию проектов на ~25%, что подтверждено практиками мониторинга на объектах «Лахта Центр» и «Бирюлевское» (itweek.ru).</a:t>
+            </a:r>
+          </a:p>
+        </p:txBody>
+      </p:sp>
+      <p:sp>
+        <p:nvSpPr>
+          <p:cNvPr id="5" name="TextBox 4"/>
+          <p:cNvSpPr txBox="1"/>
+          <p:nvPr/>
+        </p:nvSpPr>
+        <p:spPr>
+          <a:xfrm>
+            <a:off x="360000" y="3240000"/>
+            <a:ext cx="11471695" cy="900000"/>
+          </a:xfrm>
+          <a:prstGeom prst="rect">
+            <a:avLst/>
+          </a:prstGeom>
+          <a:noFill/>
+        </p:spPr>
+        <p:txBody>
+          <a:bodyPr wrap="square" lIns="36000" rIns="36000" tIns="18000" bIns="18000">
+            <a:spAutoFit/>
+          </a:bodyPr>
+          <a:lstStyle/>
+          <a:p>
+            <a:pPr algn="l"/>
+            <a:r>
+              <a:rPr sz="4000" b="1" i="0">
+                <a:solidFill>
+                  <a:srgbClr val="2E86C1"/>
+                </a:solidFill>
+                <a:latin typeface="Arial"/>
+              </a:rPr>
+              <a:t>Интеграция цифровых двойников ускоряет реализацию проектов на ~25% (itweek.ru).</a:t>
+            </a:r>
+          </a:p>
+        </p:txBody>
+      </p:sp>
+      <p:sp>
+        <p:nvSpPr>
+          <p:cNvPr id="6" name="TextBox 5"/>
+          <p:cNvSpPr txBox="1"/>
+          <p:nvPr/>
+        </p:nvSpPr>
+        <p:spPr>
+          <a:xfrm>
+            <a:off x="360000" y="4680000"/>
+            <a:ext cx="11471695" cy="360000"/>
+          </a:xfrm>
+          <a:prstGeom prst="rect">
+            <a:avLst/>
+          </a:prstGeom>
+          <a:noFill/>
+        </p:spPr>
+        <p:txBody>
+          <a:bodyPr wrap="square" lIns="36000" rIns="36000" tIns="18000" bIns="18000">
+            <a:spAutoFit/>
+          </a:bodyPr>
+          <a:lstStyle/>
+          <a:p>
+            <a:pPr algn="l"/>
+            <a:r>
+              <a:rPr sz="1200" b="0" i="1">
+                <a:solidFill>
+                  <a:srgbClr val="555555"/>
+                </a:solidFill>
+                <a:latin typeface="Arial"/>
+              </a:rPr>
+              <a:t>[Технологии и цифровизация строительства / Глобальные инновации]</a:t>
+            </a:r>
+          </a:p>
+        </p:txBody>
+      </p:sp>
     </p:spTree>
   </p:cSld>
   <p:clrMapOvr>
@@ -3952,7 +5633,7 @@
         <p:spPr>
           <a:xfrm>
             <a:off x="540000" y="360000"/>
-            <a:ext cx="11111695" cy="360000"/>
+            <a:ext cx="3600000" cy="360000"/>
           </a:xfrm>
           <a:prstGeom prst="rect">
             <a:avLst/>
@@ -3973,7 +5654,7 @@
                 </a:solidFill>
                 <a:latin typeface="Arial"/>
               </a:rPr>
-              <a:t>ТЕПЛОВАЯ КАРТА ПРИОРИТЕТОВ</a:t>
+              <a:t>НАХОДКА #2</a:t>
             </a:r>
           </a:p>
         </p:txBody>
@@ -3986,8 +5667,8 @@
         </p:nvSpPr>
         <p:spPr>
           <a:xfrm>
-            <a:off x="360000" y="720000"/>
-            <a:ext cx="11471695" cy="360000"/>
+            <a:off x="360000" y="1080000"/>
+            <a:ext cx="11471695" cy="1440000"/>
           </a:xfrm>
           <a:prstGeom prst="rect">
             <a:avLst/>
@@ -4002,41 +5683,87 @@
           <a:p>
             <a:pPr algn="l"/>
             <a:r>
-              <a:rPr sz="1200" b="0" i="1">
-                <a:solidFill>
-                  <a:srgbClr val="555555"/>
+              <a:rPr sz="2200" b="1" i="0">
+                <a:solidFill>
+                  <a:srgbClr val="1B3A5C"/>
                 </a:solidFill>
                 <a:latin typeface="Arial"/>
               </a:rPr>
-              <a:t>Где золото, где пусто</a:t>
-            </a:r>
-          </a:p>
-        </p:txBody>
-      </p:sp>
-      <p:pic>
-        <p:nvPicPr>
-          <p:cNvPr id="5" name="Picture 4" descr="20260415-world-trends-housing-heatmap.png"/>
-          <p:cNvPicPr>
-            <a:picLocks noChangeAspect="1"/>
-          </p:cNvPicPr>
-          <p:nvPr/>
-        </p:nvPicPr>
-        <p:blipFill>
-          <a:blip r:embed="rId2"/>
-          <a:stretch>
-            <a:fillRect/>
-          </a:stretch>
-        </p:blipFill>
-        <p:spPr>
-          <a:xfrm>
-            <a:off x="2122138" y="1260000"/>
-            <a:ext cx="7947419" cy="5058000"/>
-          </a:xfrm>
-          <a:prstGeom prst="rect">
-            <a:avLst/>
-          </a:prstGeom>
-        </p:spPr>
-      </p:pic>
+              <a:t>Доля домохозяйств из одного человека в РФ достигла 41,8% (27,6 млн), впервые став преобладающим типом, а ИЖС формирует &gt;56% годового ввода жилья (РБК/Росстат, Российская газета).</a:t>
+            </a:r>
+          </a:p>
+        </p:txBody>
+      </p:sp>
+      <p:sp>
+        <p:nvSpPr>
+          <p:cNvPr id="5" name="TextBox 4"/>
+          <p:cNvSpPr txBox="1"/>
+          <p:nvPr/>
+        </p:nvSpPr>
+        <p:spPr>
+          <a:xfrm>
+            <a:off x="360000" y="3240000"/>
+            <a:ext cx="11471695" cy="900000"/>
+          </a:xfrm>
+          <a:prstGeom prst="rect">
+            <a:avLst/>
+          </a:prstGeom>
+          <a:noFill/>
+        </p:spPr>
+        <p:txBody>
+          <a:bodyPr wrap="square" lIns="36000" rIns="36000" tIns="18000" bIns="18000">
+            <a:spAutoFit/>
+          </a:bodyPr>
+          <a:lstStyle/>
+          <a:p>
+            <a:pPr algn="l"/>
+            <a:r>
+              <a:rPr sz="4000" b="1" i="0">
+                <a:solidFill>
+                  <a:srgbClr val="2E86C1"/>
+                </a:solidFill>
+                <a:latin typeface="Arial"/>
+              </a:rPr>
+              <a:t>Доля домохозяйств из одного человека выросла до 41,8% (27,6 млн), а ИЖС формирует &gt;56% годового ввода жилья (РБК/Росстат, РГ).</a:t>
+            </a:r>
+          </a:p>
+        </p:txBody>
+      </p:sp>
+      <p:sp>
+        <p:nvSpPr>
+          <p:cNvPr id="6" name="TextBox 5"/>
+          <p:cNvSpPr txBox="1"/>
+          <p:nvPr/>
+        </p:nvSpPr>
+        <p:spPr>
+          <a:xfrm>
+            <a:off x="360000" y="4680000"/>
+            <a:ext cx="11471695" cy="360000"/>
+          </a:xfrm>
+          <a:prstGeom prst="rect">
+            <a:avLst/>
+          </a:prstGeom>
+          <a:noFill/>
+        </p:spPr>
+        <p:txBody>
+          <a:bodyPr wrap="square" lIns="36000" rIns="36000" tIns="18000" bIns="18000">
+            <a:spAutoFit/>
+          </a:bodyPr>
+          <a:lstStyle/>
+          <a:p>
+            <a:pPr algn="l"/>
+            <a:r>
+              <a:rPr sz="1200" b="0" i="1">
+                <a:solidFill>
+                  <a:srgbClr val="555555"/>
+                </a:solidFill>
+                <a:latin typeface="Arial"/>
+              </a:rPr>
+              <a:t>[Демография и миграционные потоки / Структура домохозяйств и типология спроса]</a:t>
+            </a:r>
+          </a:p>
+        </p:txBody>
+      </p:sp>
     </p:spTree>
   </p:cSld>
   <p:clrMapOvr>
@@ -4070,7 +5797,7 @@
             <a:avLst/>
           </a:prstGeom>
           <a:solidFill>
-            <a:srgbClr val="C0392B"/>
+            <a:srgbClr val="1B3A5C"/>
           </a:solidFill>
           <a:ln>
             <a:noFill/>
@@ -4107,7 +5834,7 @@
         <p:spPr>
           <a:xfrm>
             <a:off x="540000" y="360000"/>
-            <a:ext cx="11111695" cy="360000"/>
+            <a:ext cx="3600000" cy="360000"/>
           </a:xfrm>
           <a:prstGeom prst="rect">
             <a:avLst/>
@@ -4128,7 +5855,112 @@
                 </a:solidFill>
                 <a:latin typeface="Arial"/>
               </a:rPr>
-              <a:t>КРИТИЧЕСКИЕ ПРОБЕЛЫ И СЛЕДУЮЩИЕ ШАГИ</a:t>
+              <a:t>НАХОДКА #3</a:t>
+            </a:r>
+          </a:p>
+        </p:txBody>
+      </p:sp>
+      <p:sp>
+        <p:nvSpPr>
+          <p:cNvPr id="4" name="TextBox 3"/>
+          <p:cNvSpPr txBox="1"/>
+          <p:nvPr/>
+        </p:nvSpPr>
+        <p:spPr>
+          <a:xfrm>
+            <a:off x="360000" y="1080000"/>
+            <a:ext cx="11471695" cy="1440000"/>
+          </a:xfrm>
+          <a:prstGeom prst="rect">
+            <a:avLst/>
+          </a:prstGeom>
+          <a:noFill/>
+        </p:spPr>
+        <p:txBody>
+          <a:bodyPr wrap="square" lIns="36000" rIns="36000" tIns="18000" bIns="18000">
+            <a:spAutoFit/>
+          </a:bodyPr>
+          <a:lstStyle/>
+          <a:p>
+            <a:pPr algn="l"/>
+            <a:r>
+              <a:rPr sz="2200" b="1" i="0">
+                <a:solidFill>
+                  <a:srgbClr val="1B3A5C"/>
+                </a:solidFill>
+                <a:latin typeface="Arial"/>
+              </a:rPr>
+              <a:t>Инвестиционные сделки на рынке недвижимости выросли до 47%, тогда как доля граждан, планирующих покупку жилья для себя, упала до 16% (ВЦИОМ/ДОМ.РФ).</a:t>
+            </a:r>
+          </a:p>
+        </p:txBody>
+      </p:sp>
+      <p:sp>
+        <p:nvSpPr>
+          <p:cNvPr id="5" name="TextBox 4"/>
+          <p:cNvSpPr txBox="1"/>
+          <p:nvPr/>
+        </p:nvSpPr>
+        <p:spPr>
+          <a:xfrm>
+            <a:off x="360000" y="3240000"/>
+            <a:ext cx="11471695" cy="900000"/>
+          </a:xfrm>
+          <a:prstGeom prst="rect">
+            <a:avLst/>
+          </a:prstGeom>
+          <a:noFill/>
+        </p:spPr>
+        <p:txBody>
+          <a:bodyPr wrap="square" lIns="36000" rIns="36000" tIns="18000" bIns="18000">
+            <a:spAutoFit/>
+          </a:bodyPr>
+          <a:lstStyle/>
+          <a:p>
+            <a:pPr algn="l"/>
+            <a:r>
+              <a:rPr sz="4000" b="1" i="0">
+                <a:solidFill>
+                  <a:srgbClr val="2E86C1"/>
+                </a:solidFill>
+                <a:latin typeface="Arial"/>
+              </a:rPr>
+              <a:t>Доля инвестиционных сделок достигла 47%, при этом 46% покупателей требуют 3+ комнат, а на рынке их лишь 14% (irn.ru, ДОМ.РФ).</a:t>
+            </a:r>
+          </a:p>
+        </p:txBody>
+      </p:sp>
+      <p:sp>
+        <p:nvSpPr>
+          <p:cNvPr id="6" name="TextBox 5"/>
+          <p:cNvSpPr txBox="1"/>
+          <p:nvPr/>
+        </p:nvSpPr>
+        <p:spPr>
+          <a:xfrm>
+            <a:off x="360000" y="4680000"/>
+            <a:ext cx="11471695" cy="360000"/>
+          </a:xfrm>
+          <a:prstGeom prst="rect">
+            <a:avLst/>
+          </a:prstGeom>
+          <a:noFill/>
+        </p:spPr>
+        <p:txBody>
+          <a:bodyPr wrap="square" lIns="36000" rIns="36000" tIns="18000" bIns="18000">
+            <a:spAutoFit/>
+          </a:bodyPr>
+          <a:lstStyle/>
+          <a:p>
+            <a:pPr algn="l"/>
+            <a:r>
+              <a:rPr sz="1200" b="0" i="1">
+                <a:solidFill>
+                  <a:srgbClr val="555555"/>
+                </a:solidFill>
+                <a:latin typeface="Arial"/>
+              </a:rPr>
+              <a:t>[Социокультурные паттерны и урбанистика / Российские практики расселения]</a:t>
             </a:r>
           </a:p>
         </p:txBody>
@@ -4159,8 +5991,8 @@
         </p:nvSpPr>
         <p:spPr>
           <a:xfrm>
-            <a:off x="0" y="0"/>
-            <a:ext cx="12191695" cy="6858000"/>
+            <a:off x="360000" y="360000"/>
+            <a:ext cx="72000" cy="540000"/>
           </a:xfrm>
           <a:prstGeom prst="rect">
             <a:avLst/>
@@ -4202,8 +6034,8 @@
         </p:nvSpPr>
         <p:spPr>
           <a:xfrm>
-            <a:off x="360000" y="1080000"/>
-            <a:ext cx="11471695" cy="720000"/>
+            <a:off x="540000" y="360000"/>
+            <a:ext cx="3600000" cy="360000"/>
           </a:xfrm>
           <a:prstGeom prst="rect">
             <a:avLst/>
@@ -4220,11 +6052,11 @@
             <a:r>
               <a:rPr sz="1400" b="1" i="0">
                 <a:solidFill>
-                  <a:srgbClr val="FFFFFF"/>
+                  <a:srgbClr val="1B3A5C"/>
                 </a:solidFill>
                 <a:latin typeface="Arial"/>
               </a:rPr>
-              <a:t>ЗАКЛЮЧЕНИЕ</a:t>
+              <a:t>НАХОДКА #4</a:t>
             </a:r>
           </a:p>
         </p:txBody>
@@ -4237,8 +6069,8 @@
         </p:nvSpPr>
         <p:spPr>
           <a:xfrm>
-            <a:off x="360000" y="2160000"/>
-            <a:ext cx="11471695" cy="1080000"/>
+            <a:off x="360000" y="1080000"/>
+            <a:ext cx="11471695" cy="1440000"/>
           </a:xfrm>
           <a:prstGeom prst="rect">
             <a:avLst/>
@@ -4253,13 +6085,284 @@
           <a:p>
             <a:pPr algn="l"/>
             <a:r>
-              <a:rPr sz="2600" b="1" i="0">
-                <a:solidFill>
-                  <a:srgbClr val="FFFFFF"/>
+              <a:rPr sz="2200" b="1" i="0">
+                <a:solidFill>
+                  <a:srgbClr val="1B3A5C"/>
                 </a:solidFill>
                 <a:latin typeface="Arial"/>
               </a:rPr>
-              <a:t>5 доменов · 0 блоков · 0 связей</a:t>
+              <a:t>К 2030–2039 гг. температура в европейской части РФ и Сибири вырастет на 2–4°C летом, увеличивая интенсивность ливней до 50 мм/час (ГГО им. Воейкова).</a:t>
+            </a:r>
+          </a:p>
+        </p:txBody>
+      </p:sp>
+      <p:sp>
+        <p:nvSpPr>
+          <p:cNvPr id="5" name="TextBox 4"/>
+          <p:cNvSpPr txBox="1"/>
+          <p:nvPr/>
+        </p:nvSpPr>
+        <p:spPr>
+          <a:xfrm>
+            <a:off x="360000" y="3240000"/>
+            <a:ext cx="11471695" cy="900000"/>
+          </a:xfrm>
+          <a:prstGeom prst="rect">
+            <a:avLst/>
+          </a:prstGeom>
+          <a:noFill/>
+        </p:spPr>
+        <p:txBody>
+          <a:bodyPr wrap="square" lIns="36000" rIns="36000" tIns="18000" bIns="18000">
+            <a:spAutoFit/>
+          </a:bodyPr>
+          <a:lstStyle/>
+          <a:p>
+            <a:pPr algn="l"/>
+            <a:r>
+              <a:rPr sz="4000" b="1" i="0">
+                <a:solidFill>
+                  <a:srgbClr val="2E86C1"/>
+                </a:solidFill>
+                <a:latin typeface="Arial"/>
+              </a:rPr>
+              <a:t>К 2030–2039 гг. ожидается рост температуры в европейской части РФ и Сибири на 2–4°C летом при увеличении осадков на 10–20% (ГГО им. Воейкова).</a:t>
+            </a:r>
+          </a:p>
+        </p:txBody>
+      </p:sp>
+      <p:sp>
+        <p:nvSpPr>
+          <p:cNvPr id="6" name="TextBox 5"/>
+          <p:cNvSpPr txBox="1"/>
+          <p:nvPr/>
+        </p:nvSpPr>
+        <p:spPr>
+          <a:xfrm>
+            <a:off x="360000" y="4680000"/>
+            <a:ext cx="11471695" cy="360000"/>
+          </a:xfrm>
+          <a:prstGeom prst="rect">
+            <a:avLst/>
+          </a:prstGeom>
+          <a:noFill/>
+        </p:spPr>
+        <p:txBody>
+          <a:bodyPr wrap="square" lIns="36000" rIns="36000" tIns="18000" bIns="18000">
+            <a:spAutoFit/>
+          </a:bodyPr>
+          <a:lstStyle/>
+          <a:p>
+            <a:pPr algn="l"/>
+            <a:r>
+              <a:rPr sz="1200" b="0" i="1">
+                <a:solidFill>
+                  <a:srgbClr val="555555"/>
+                </a:solidFill>
+                <a:latin typeface="Arial"/>
+              </a:rPr>
+              <a:t>[Экология и климатическая адаптация / Климатические изменения в РФ]</a:t>
+            </a:r>
+          </a:p>
+        </p:txBody>
+      </p:sp>
+    </p:spTree>
+  </p:cSld>
+  <p:clrMapOvr>
+    <a:masterClrMapping/>
+  </p:clrMapOvr>
+</p:sld>
+</file>
+
+<file path=ppt/slides/slide9.xml><?xml version="1.0" encoding="utf-8"?>
+<p:sld xmlns:a="http://schemas.openxmlformats.org/drawingml/2006/main" xmlns:p="http://schemas.openxmlformats.org/presentationml/2006/main" xmlns:r="http://schemas.openxmlformats.org/officeDocument/2006/relationships">
+  <p:cSld>
+    <p:spTree>
+      <p:nvGrpSpPr>
+        <p:cNvPr id="1" name=""/>
+        <p:cNvGrpSpPr/>
+        <p:nvPr/>
+      </p:nvGrpSpPr>
+      <p:grpSpPr/>
+      <p:sp>
+        <p:nvSpPr>
+          <p:cNvPr id="2" name="Rectangle 1"/>
+          <p:cNvSpPr/>
+          <p:nvPr/>
+        </p:nvSpPr>
+        <p:spPr>
+          <a:xfrm>
+            <a:off x="360000" y="360000"/>
+            <a:ext cx="72000" cy="540000"/>
+          </a:xfrm>
+          <a:prstGeom prst="rect">
+            <a:avLst/>
+          </a:prstGeom>
+          <a:solidFill>
+            <a:srgbClr val="1B3A5C"/>
+          </a:solidFill>
+          <a:ln>
+            <a:noFill/>
+          </a:ln>
+        </p:spPr>
+        <p:style>
+          <a:lnRef idx="1">
+            <a:schemeClr val="accent1"/>
+          </a:lnRef>
+          <a:fillRef idx="3">
+            <a:schemeClr val="accent1"/>
+          </a:fillRef>
+          <a:effectRef idx="2">
+            <a:schemeClr val="accent1"/>
+          </a:effectRef>
+          <a:fontRef idx="minor">
+            <a:schemeClr val="lt1"/>
+          </a:fontRef>
+        </p:style>
+        <p:txBody>
+          <a:bodyPr rtlCol="0" anchor="ctr"/>
+          <a:lstStyle/>
+          <a:p>
+            <a:pPr algn="ctr"/>
+          </a:p>
+        </p:txBody>
+      </p:sp>
+      <p:sp>
+        <p:nvSpPr>
+          <p:cNvPr id="3" name="TextBox 2"/>
+          <p:cNvSpPr txBox="1"/>
+          <p:nvPr/>
+        </p:nvSpPr>
+        <p:spPr>
+          <a:xfrm>
+            <a:off x="540000" y="360000"/>
+            <a:ext cx="3600000" cy="360000"/>
+          </a:xfrm>
+          <a:prstGeom prst="rect">
+            <a:avLst/>
+          </a:prstGeom>
+          <a:noFill/>
+        </p:spPr>
+        <p:txBody>
+          <a:bodyPr wrap="square" lIns="36000" rIns="36000" tIns="18000" bIns="18000">
+            <a:spAutoFit/>
+          </a:bodyPr>
+          <a:lstStyle/>
+          <a:p>
+            <a:pPr algn="l"/>
+            <a:r>
+              <a:rPr sz="1400" b="1" i="0">
+                <a:solidFill>
+                  <a:srgbClr val="1B3A5C"/>
+                </a:solidFill>
+                <a:latin typeface="Arial"/>
+              </a:rPr>
+              <a:t>НАХОДКА #5</a:t>
+            </a:r>
+          </a:p>
+        </p:txBody>
+      </p:sp>
+      <p:sp>
+        <p:nvSpPr>
+          <p:cNvPr id="4" name="TextBox 3"/>
+          <p:cNvSpPr txBox="1"/>
+          <p:nvPr/>
+        </p:nvSpPr>
+        <p:spPr>
+          <a:xfrm>
+            <a:off x="360000" y="1080000"/>
+            <a:ext cx="11471695" cy="1440000"/>
+          </a:xfrm>
+          <a:prstGeom prst="rect">
+            <a:avLst/>
+          </a:prstGeom>
+          <a:noFill/>
+        </p:spPr>
+        <p:txBody>
+          <a:bodyPr wrap="square" lIns="36000" rIns="36000" tIns="18000" bIns="18000">
+            <a:spAutoFit/>
+          </a:bodyPr>
+          <a:lstStyle/>
+          <a:p>
+            <a:pPr algn="l"/>
+            <a:r>
+              <a:rPr sz="2200" b="1" i="0">
+                <a:solidFill>
+                  <a:srgbClr val="1B3A5C"/>
+                </a:solidFill>
+                <a:latin typeface="Arial"/>
+              </a:rPr>
+              <a:t>Сертификация Green Zoom адаптирована под российские нормы на 90%, но охватывает не более 30 жилых зданий по всей стране (Коммерсантъ).</a:t>
+            </a:r>
+          </a:p>
+        </p:txBody>
+      </p:sp>
+      <p:sp>
+        <p:nvSpPr>
+          <p:cNvPr id="5" name="TextBox 4"/>
+          <p:cNvSpPr txBox="1"/>
+          <p:nvPr/>
+        </p:nvSpPr>
+        <p:spPr>
+          <a:xfrm>
+            <a:off x="360000" y="3240000"/>
+            <a:ext cx="11471695" cy="900000"/>
+          </a:xfrm>
+          <a:prstGeom prst="rect">
+            <a:avLst/>
+          </a:prstGeom>
+          <a:noFill/>
+        </p:spPr>
+        <p:txBody>
+          <a:bodyPr wrap="square" lIns="36000" rIns="36000" tIns="18000" bIns="18000">
+            <a:spAutoFit/>
+          </a:bodyPr>
+          <a:lstStyle/>
+          <a:p>
+            <a:pPr algn="l"/>
+            <a:r>
+              <a:rPr sz="4000" b="1" i="0">
+                <a:solidFill>
+                  <a:srgbClr val="2E86C1"/>
+                </a:solidFill>
+                <a:latin typeface="Arial"/>
+              </a:rPr>
+              <a:t>Green Zoom адаптирована под российские нормы на 90%, но сертифицировано не более 30 жилых зданий по всей России (Green Zoom, Коммерсантъ).</a:t>
+            </a:r>
+          </a:p>
+        </p:txBody>
+      </p:sp>
+      <p:sp>
+        <p:nvSpPr>
+          <p:cNvPr id="6" name="TextBox 5"/>
+          <p:cNvSpPr txBox="1"/>
+          <p:nvPr/>
+        </p:nvSpPr>
+        <p:spPr>
+          <a:xfrm>
+            <a:off x="360000" y="4680000"/>
+            <a:ext cx="11471695" cy="360000"/>
+          </a:xfrm>
+          <a:prstGeom prst="rect">
+            <a:avLst/>
+          </a:prstGeom>
+          <a:noFill/>
+        </p:spPr>
+        <p:txBody>
+          <a:bodyPr wrap="square" lIns="36000" rIns="36000" tIns="18000" bIns="18000">
+            <a:spAutoFit/>
+          </a:bodyPr>
+          <a:lstStyle/>
+          <a:p>
+            <a:pPr algn="l"/>
+            <a:r>
+              <a:rPr sz="1200" b="0" i="1">
+                <a:solidFill>
+                  <a:srgbClr val="555555"/>
+                </a:solidFill>
+                <a:latin typeface="Arial"/>
+              </a:rPr>
+              <a:t>[Экология и климатическая адаптация / Зелёные материалы и рыночный спрос]</a:t>
             </a:r>
           </a:p>
         </p:txBody>

</xml_diff>